<commit_message>
updated Powerpoint with "merkmale"
</commit_message>
<xml_diff>
--- a/Task_2/Task2Powerpoint.pptx
+++ b/Task_2/Task2Powerpoint.pptx
@@ -5,15 +5,16 @@
     <p:sldMasterId id="2147483648" r:id="rId1"/>
   </p:sldMasterIdLst>
   <p:notesMasterIdLst>
-    <p:notesMasterId r:id="rId8"/>
+    <p:notesMasterId r:id="rId9"/>
   </p:notesMasterIdLst>
   <p:sldIdLst>
     <p:sldId id="256" r:id="rId2"/>
     <p:sldId id="257" r:id="rId3"/>
     <p:sldId id="258" r:id="rId4"/>
     <p:sldId id="261" r:id="rId5"/>
-    <p:sldId id="259" r:id="rId6"/>
-    <p:sldId id="260" r:id="rId7"/>
+    <p:sldId id="262" r:id="rId6"/>
+    <p:sldId id="259" r:id="rId7"/>
+    <p:sldId id="260" r:id="rId8"/>
   </p:sldIdLst>
   <p:sldSz cx="12192000" cy="6858000"/>
   <p:notesSz cx="9144000" cy="6858000"/>
@@ -157,6 +158,9 @@
         </p15:guide>
       </p15:sldGuideLst>
     </p:ext>
+    <p:ext uri="{2D200454-40CA-4A62-9FC3-DE9A4176ACB9}">
+      <p15:notesGuideLst xmlns:p15="http://schemas.microsoft.com/office/powerpoint/2012/main"/>
+    </p:ext>
   </p:extLst>
 </p:presentation>
 </file>
@@ -243,7 +247,7 @@
           <a:p>
             <a:fld id="{52D5829F-2F94-0B44-A96D-AE852A87AC61}" type="datetimeFigureOut">
               <a:rPr lang="de-DE" smtClean="0"/>
-              <a:t>13.06.26</a:t>
+              <a:t>15.06.26</a:t>
             </a:fld>
             <a:endParaRPr lang="de-DE"/>
           </a:p>
@@ -3811,7 +3815,22 @@
           <a:p>
             <a:r>
               <a:rPr lang="de-DE" dirty="0"/>
-              <a:t>Merkmalsanalyse</a:t>
+              <a:t>Merkmalsanalyse (Feature </a:t>
+            </a:r>
+            <a:r>
+              <a:rPr lang="de-DE" dirty="0" err="1"/>
+              <a:t>Extraction</a:t>
+            </a:r>
+            <a:r>
+              <a:rPr lang="de-DE" dirty="0"/>
+              <a:t>)</a:t>
+            </a:r>
+          </a:p>
+          <a:p>
+            <a:pPr lvl="1"/>
+            <a:r>
+              <a:rPr lang="de-DE" dirty="0"/>
+              <a:t>Betrachtete Merkmale</a:t>
             </a:r>
           </a:p>
           <a:p>
@@ -3836,7 +3855,10 @@
           </a:p>
           <a:p>
             <a:pPr lvl="1"/>
-            <a:endParaRPr lang="de-DE" dirty="0"/>
+            <a:r>
+              <a:rPr lang="de-DE" dirty="0"/>
+              <a:t>?</a:t>
+            </a:r>
           </a:p>
           <a:p>
             <a:pPr lvl="1"/>
@@ -4060,6 +4082,17 @@
               <a:rPr lang="de-DE" dirty="0" err="1"/>
               <a:t>Mekmalsanalyse</a:t>
             </a:r>
+            <a:r>
+              <a:rPr lang="de-DE" dirty="0"/>
+              <a:t>:</a:t>
+            </a:r>
+            <a:br>
+              <a:rPr lang="de-DE" dirty="0"/>
+            </a:br>
+            <a:r>
+              <a:rPr lang="de-DE" sz="2400" dirty="0"/>
+              <a:t>Betrachtete Merkmale</a:t>
+            </a:r>
             <a:endParaRPr lang="de-DE" dirty="0"/>
           </a:p>
         </p:txBody>
@@ -4087,36 +4120,90 @@
           <a:p>
             <a:r>
               <a:rPr lang="de-DE" dirty="0"/>
-              <a:t>Welche </a:t>
-            </a:r>
+              <a:t>1. Spektrale Merkmale (Frequenzbereich)</a:t>
+            </a:r>
+          </a:p>
+          <a:p>
+            <a:pPr lvl="1"/>
+            <a:r>
+              <a:rPr lang="de-DE" dirty="0"/>
+              <a:t>MFCCs (13 Koeffizienten): Bilden die Spektraleinhüllende auf der Mel-Skala ab </a:t>
+            </a:r>
+          </a:p>
+          <a:p>
+            <a:pPr lvl="1"/>
             <a:r>
               <a:rPr lang="de-DE" dirty="0" err="1"/>
-              <a:t>merkmale</a:t>
+              <a:t>Spectral</a:t>
             </a:r>
             <a:r>
               <a:rPr lang="de-DE" dirty="0"/>
-              <a:t> gibt es/haben wir </a:t>
+              <a:t> </a:t>
+            </a:r>
+            <a:r>
+              <a:rPr lang="de-DE" dirty="0" err="1"/>
+              <a:t>Centroid</a:t>
+            </a:r>
+            <a:r>
+              <a:rPr lang="de-DE" dirty="0"/>
+              <a:t> (Schwerpunkt):Gibt an, bei welcher Frequenz der "Masseschwerpunkt" des Spektrums liegt. Maß für die "Helligkeit" des Klangs.</a:t>
             </a:r>
           </a:p>
           <a:p>
             <a:pPr lvl="1"/>
             <a:r>
+              <a:rPr lang="de-DE" dirty="0" err="1"/>
+              <a:t>Spectral</a:t>
+            </a:r>
+            <a:r>
               <a:rPr lang="de-DE" dirty="0"/>
-              <a:t>-&gt; zu finden in </a:t>
+              <a:t> </a:t>
             </a:r>
             <a:r>
               <a:rPr lang="de-DE" dirty="0" err="1"/>
-              <a:t>src</a:t>
+              <a:t>Bandwidth</a:t>
             </a:r>
             <a:r>
               <a:rPr lang="de-DE" dirty="0"/>
-              <a:t>/</a:t>
-            </a:r>
+              <a:t> (Bandbreite): Beschreibt die Spreizung des Spektrums um den Schwerpunkt</a:t>
+            </a:r>
+          </a:p>
+          <a:p>
+            <a:pPr lvl="1"/>
             <a:r>
               <a:rPr lang="de-DE" dirty="0" err="1"/>
-              <a:t>gear_analysis</a:t>
-            </a:r>
-            <a:endParaRPr lang="de-DE" dirty="0"/>
+              <a:t>Spectral</a:t>
+            </a:r>
+            <a:r>
+              <a:rPr lang="de-DE" dirty="0"/>
+              <a:t> Roll-off: Die Frequenz, unter der ein bestimmter Prozentsatz (meist 85%) der Spektralenergie liegt</a:t>
+            </a:r>
+          </a:p>
+          <a:p>
+            <a:pPr lvl="1"/>
+            <a:r>
+              <a:rPr lang="de-DE" dirty="0" err="1"/>
+              <a:t>Spectral</a:t>
+            </a:r>
+            <a:r>
+              <a:rPr lang="de-DE" dirty="0"/>
+              <a:t> </a:t>
+            </a:r>
+            <a:r>
+              <a:rPr lang="de-DE" dirty="0" err="1"/>
+              <a:t>Contrast</a:t>
+            </a:r>
+            <a:r>
+              <a:rPr lang="de-DE" dirty="0"/>
+              <a:t>: Misst den Unterschied zwischen Spitzen und Tälern im Spektrum.</a:t>
+            </a:r>
+          </a:p>
+          <a:p>
+            <a:pPr lvl="1"/>
+            <a:r>
+              <a:rPr lang="de-DE" dirty="0"/>
+              <a:t>Chroma Features (STFT/CENS): Projizieren das gesamte Spektrum auf 12 Halbtonklassen</a:t>
+            </a:r>
           </a:p>
         </p:txBody>
       </p:sp>
@@ -4169,6 +4256,172 @@
 </file>
 
 <file path=ppt/slides/slide5.xml><?xml version="1.0" encoding="utf-8"?>
+<p:sld xmlns:a="http://schemas.openxmlformats.org/drawingml/2006/main" xmlns:r="http://schemas.openxmlformats.org/officeDocument/2006/relationships" xmlns:p="http://schemas.openxmlformats.org/presentationml/2006/main">
+  <p:cSld>
+    <p:spTree>
+      <p:nvGrpSpPr>
+        <p:cNvPr id="1" name="">
+          <a:extLst>
+            <a:ext uri="{FF2B5EF4-FFF2-40B4-BE49-F238E27FC236}">
+              <a16:creationId xmlns:a16="http://schemas.microsoft.com/office/drawing/2014/main" id="{0F570CD2-0EFA-C90D-FDB3-9ADFD1668184}"/>
+            </a:ext>
+          </a:extLst>
+        </p:cNvPr>
+        <p:cNvGrpSpPr/>
+        <p:nvPr/>
+      </p:nvGrpSpPr>
+      <p:grpSpPr>
+        <a:xfrm>
+          <a:off x="0" y="0"/>
+          <a:ext cx="0" cy="0"/>
+          <a:chOff x="0" y="0"/>
+          <a:chExt cx="0" cy="0"/>
+        </a:xfrm>
+      </p:grpSpPr>
+      <p:sp>
+        <p:nvSpPr>
+          <p:cNvPr id="5" name="Titel 4">
+            <a:extLst>
+              <a:ext uri="{FF2B5EF4-FFF2-40B4-BE49-F238E27FC236}">
+                <a16:creationId xmlns:a16="http://schemas.microsoft.com/office/drawing/2014/main" id="{319D2184-7ACE-A16F-5F1A-5155AEBDB03E}"/>
+              </a:ext>
+            </a:extLst>
+          </p:cNvPr>
+          <p:cNvSpPr>
+            <a:spLocks noGrp="1"/>
+          </p:cNvSpPr>
+          <p:nvPr>
+            <p:ph type="title"/>
+          </p:nvPr>
+        </p:nvSpPr>
+        <p:spPr/>
+        <p:txBody>
+          <a:bodyPr/>
+          <a:lstStyle/>
+          <a:p>
+            <a:r>
+              <a:rPr lang="de-DE" dirty="0" err="1"/>
+              <a:t>Mekmalsanalyse</a:t>
+            </a:r>
+            <a:r>
+              <a:rPr lang="de-DE" dirty="0"/>
+              <a:t>:</a:t>
+            </a:r>
+            <a:br>
+              <a:rPr lang="de-DE" dirty="0"/>
+            </a:br>
+            <a:r>
+              <a:rPr lang="de-DE" sz="2400" dirty="0"/>
+              <a:t>Betrachtete Merkmale &amp; PCA</a:t>
+            </a:r>
+            <a:endParaRPr lang="de-DE" dirty="0"/>
+          </a:p>
+        </p:txBody>
+      </p:sp>
+      <p:sp>
+        <p:nvSpPr>
+          <p:cNvPr id="10" name="Inhaltsplatzhalter 9">
+            <a:extLst>
+              <a:ext uri="{FF2B5EF4-FFF2-40B4-BE49-F238E27FC236}">
+                <a16:creationId xmlns:a16="http://schemas.microsoft.com/office/drawing/2014/main" id="{19C4C79F-28B8-72C8-A1FA-5C00426D9315}"/>
+              </a:ext>
+            </a:extLst>
+          </p:cNvPr>
+          <p:cNvSpPr>
+            <a:spLocks noGrp="1"/>
+          </p:cNvSpPr>
+          <p:nvPr>
+            <p:ph idx="1"/>
+          </p:nvPr>
+        </p:nvSpPr>
+        <p:spPr/>
+        <p:txBody>
+          <a:bodyPr/>
+          <a:lstStyle/>
+          <a:p>
+            <a:r>
+              <a:rPr lang="de-DE" dirty="0"/>
+              <a:t>2. Zeitbereichs-Merkmale</a:t>
+            </a:r>
+          </a:p>
+          <a:p>
+            <a:pPr lvl="1"/>
+            <a:r>
+              <a:rPr lang="de-DE" dirty="0"/>
+              <a:t>Zero Crossing Rate (ZCR): Die Rate, mit der das Signal die Nulllinie kreuzt. Ein Maß für die Frequenz und Impulsivität (Rauschen)</a:t>
+            </a:r>
+          </a:p>
+          <a:p>
+            <a:pPr lvl="1"/>
+            <a:r>
+              <a:rPr lang="de-DE" dirty="0"/>
+              <a:t>Frame Energy (RMS): Der quadratische Mittelwert der Amplitude.</a:t>
+            </a:r>
+          </a:p>
+          <a:p>
+            <a:r>
+              <a:rPr lang="de-DE" dirty="0"/>
+              <a:t>3. Dynamische Merkmale</a:t>
+            </a:r>
+          </a:p>
+          <a:p>
+            <a:pPr lvl="1"/>
+            <a:r>
+              <a:rPr lang="de-DE" dirty="0"/>
+              <a:t>Delta-Features: Die erste zeitliche Ableitung der MFCCs.</a:t>
+            </a:r>
+          </a:p>
+        </p:txBody>
+      </p:sp>
+      <p:sp>
+        <p:nvSpPr>
+          <p:cNvPr id="4" name="Foliennummernplatzhalter 3">
+            <a:extLst>
+              <a:ext uri="{FF2B5EF4-FFF2-40B4-BE49-F238E27FC236}">
+                <a16:creationId xmlns:a16="http://schemas.microsoft.com/office/drawing/2014/main" id="{2E80E235-26A6-A7CB-B35C-87EBFB13852B}"/>
+              </a:ext>
+            </a:extLst>
+          </p:cNvPr>
+          <p:cNvSpPr>
+            <a:spLocks noGrp="1"/>
+          </p:cNvSpPr>
+          <p:nvPr>
+            <p:ph type="sldNum" sz="quarter" idx="10"/>
+          </p:nvPr>
+        </p:nvSpPr>
+        <p:spPr/>
+        <p:txBody>
+          <a:bodyPr/>
+          <a:lstStyle/>
+          <a:p>
+            <a:pPr>
+              <a:defRPr/>
+            </a:pPr>
+            <a:fld id="{A0424531-ACBB-43B0-9536-C2FB0D769E6C}" type="slidenum">
+              <a:rPr lang="de-DE" altLang="de-DE" smtClean="0"/>
+              <a:pPr>
+                <a:defRPr/>
+              </a:pPr>
+              <a:t>5</a:t>
+            </a:fld>
+            <a:endParaRPr lang="de-DE" altLang="de-DE" dirty="0"/>
+          </a:p>
+        </p:txBody>
+      </p:sp>
+    </p:spTree>
+    <p:extLst>
+      <p:ext uri="{BB962C8B-B14F-4D97-AF65-F5344CB8AC3E}">
+        <p14:creationId xmlns:p14="http://schemas.microsoft.com/office/powerpoint/2010/main" val="2854101102"/>
+      </p:ext>
+    </p:extLst>
+  </p:cSld>
+  <p:clrMapOvr>
+    <a:masterClrMapping/>
+  </p:clrMapOvr>
+</p:sld>
+</file>
+
+<file path=ppt/slides/slide6.xml><?xml version="1.0" encoding="utf-8"?>
 <p:sld xmlns:a="http://schemas.openxmlformats.org/drawingml/2006/main" xmlns:r="http://schemas.openxmlformats.org/officeDocument/2006/relationships" xmlns:p="http://schemas.openxmlformats.org/presentationml/2006/main">
   <p:cSld>
     <p:spTree>
@@ -4355,7 +4608,7 @@
               <a:pPr>
                 <a:defRPr/>
               </a:pPr>
-              <a:t>5</a:t>
+              <a:t>6</a:t>
             </a:fld>
             <a:endParaRPr lang="de-DE" altLang="de-DE" dirty="0"/>
           </a:p>
@@ -4374,7 +4627,7 @@
 </p:sld>
 </file>
 
-<file path=ppt/slides/slide6.xml><?xml version="1.0" encoding="utf-8"?>
+<file path=ppt/slides/slide7.xml><?xml version="1.0" encoding="utf-8"?>
 <p:sld xmlns:a="http://schemas.openxmlformats.org/drawingml/2006/main" xmlns:r="http://schemas.openxmlformats.org/officeDocument/2006/relationships" xmlns:p="http://schemas.openxmlformats.org/presentationml/2006/main">
   <p:cSld>
     <p:spTree>
@@ -4486,7 +4739,7 @@
               <a:pPr>
                 <a:defRPr/>
               </a:pPr>
-              <a:t>6</a:t>
+              <a:t>7</a:t>
             </a:fld>
             <a:endParaRPr lang="de-DE" altLang="de-DE" dirty="0"/>
           </a:p>

</xml_diff>

<commit_message>
deleted inital pptx, README.txt changed ToDo, gear-analysis and Task2 pptx
</commit_message>
<xml_diff>
--- a/Task_2/Task2Powerpoint.pptx
+++ b/Task_2/Task2Powerpoint.pptx
@@ -247,7 +247,7 @@
           <a:p>
             <a:fld id="{52D5829F-2F94-0B44-A96D-AE852A87AC61}" type="datetimeFigureOut">
               <a:rPr lang="de-DE" smtClean="0"/>
-              <a:t>15.06.26</a:t>
+              <a:t>18.06.2026</a:t>
             </a:fld>
             <a:endParaRPr lang="de-DE"/>
           </a:p>
@@ -3857,7 +3857,7 @@
             <a:pPr lvl="1"/>
             <a:r>
               <a:rPr lang="de-DE" dirty="0"/>
-              <a:t>?</a:t>
+              <a:t>Erklären PC1 und PC2 der PCA</a:t>
             </a:r>
           </a:p>
           <a:p>
@@ -3881,18 +3881,10 @@
             </a:r>
           </a:p>
           <a:p>
-            <a:pPr lvl="1"/>
             <a:r>
               <a:rPr lang="de-DE" dirty="0"/>
-              <a:t>Code</a:t>
-            </a:r>
-          </a:p>
-          <a:p>
-            <a:r>
-              <a:rPr lang="de-DE" dirty="0" err="1"/>
-              <a:t>Ergebnise</a:t>
-            </a:r>
-            <a:endParaRPr lang="de-DE" dirty="0"/>
+              <a:t>Ergebnisse</a:t>
+            </a:r>
           </a:p>
           <a:p>
             <a:endParaRPr lang="de-DE" dirty="0"/>
@@ -4146,7 +4138,7 @@
             </a:r>
             <a:r>
               <a:rPr lang="de-DE" dirty="0"/>
-              <a:t> (Schwerpunkt):Gibt an, bei welcher Frequenz der "Masseschwerpunkt" des Spektrums liegt. Maß für die "Helligkeit" des Klangs.</a:t>
+              <a:t> (Schwerpunkt): Gibt an, bei welcher Frequenz der "Masseschwerpunkt" des Spektrums liegt. Maß für die "Helligkeit" des Klangs.</a:t>
             </a:r>
           </a:p>
           <a:p>

</xml_diff>

<commit_message>
updated pptx and ToDo
</commit_message>
<xml_diff>
--- a/Task_2/Task2Powerpoint.pptx
+++ b/Task_2/Task2Powerpoint.pptx
@@ -273,7 +273,7 @@
           <a:p>
             <a:fld id="{75AB4CA9-CCE6-4DE5-84AD-E1F7B6CB5CBB}" type="datetimeFigureOut">
               <a:rPr lang="de-DE" smtClean="0"/>
-              <a:t>22.06.26</a:t>
+              <a:t>24.06.2026</a:t>
             </a:fld>
             <a:endParaRPr lang="de-DE"/>
           </a:p>
@@ -450,7 +450,7 @@
           <a:p>
             <a:fld id="{52D5829F-2F94-0B44-A96D-AE852A87AC61}" type="datetimeFigureOut">
               <a:rPr lang="de-DE" smtClean="0"/>
-              <a:t>22.06.26</a:t>
+              <a:t>24.06.2026</a:t>
             </a:fld>
             <a:endParaRPr lang="de-DE"/>
           </a:p>
@@ -763,7 +763,7 @@
           <a:p>
             <a:r>
               <a:rPr lang="de-DE" dirty="0"/>
-              <a:t>(S)</a:t>
+              <a:t>D</a:t>
             </a:r>
           </a:p>
           <a:p>
@@ -877,7 +877,7 @@
             </a:pPr>
             <a:r>
               <a:rPr lang="de-DE" dirty="0"/>
-              <a:t>(S)</a:t>
+              <a:t>T</a:t>
             </a:r>
           </a:p>
           <a:p>
@@ -1762,7 +1762,7 @@
           <a:p>
             <a:r>
               <a:rPr lang="de-DE" dirty="0"/>
-              <a:t>(S)</a:t>
+              <a:t>D</a:t>
             </a:r>
           </a:p>
         </p:txBody>
@@ -1849,7 +1849,7 @@
           <a:p>
             <a:r>
               <a:rPr lang="de-DE" dirty="0"/>
-              <a:t>(S)</a:t>
+              <a:t>D</a:t>
             </a:r>
           </a:p>
         </p:txBody>
@@ -1943,7 +1943,7 @@
           <a:p>
             <a:r>
               <a:rPr lang="de-DE" dirty="0"/>
-              <a:t>(D)</a:t>
+              <a:t>D</a:t>
             </a:r>
           </a:p>
           <a:p>
@@ -2118,7 +2118,7 @@
           <a:p>
             <a:r>
               <a:rPr lang="de-DE" dirty="0"/>
-              <a:t>(D)</a:t>
+              <a:t>D</a:t>
             </a:r>
           </a:p>
         </p:txBody>
@@ -2330,7 +2330,62 @@
             </a:r>
           </a:p>
           <a:p>
-            <a:endParaRPr lang="de-DE" dirty="0"/>
+            <a:pPr marL="171450" indent="-171450">
+              <a:buFontTx/>
+              <a:buChar char="-"/>
+            </a:pPr>
+            <a:r>
+              <a:rPr lang="de-DE" dirty="0"/>
+              <a:t>Lage der Mediane zueinander: wenn Mediane von Zahnrädern aus versch. </a:t>
+            </a:r>
+            <a:r>
+              <a:rPr lang="de-DE" dirty="0" err="1"/>
+              <a:t>klassen</a:t>
+            </a:r>
+            <a:r>
+              <a:rPr lang="de-DE" dirty="0"/>
+              <a:t> unterschiedlich stark sind hat dieses Merkmal einen indikativen Charakter  </a:t>
+            </a:r>
+            <a:br>
+              <a:rPr lang="de-DE" dirty="0"/>
+            </a:br>
+            <a:r>
+              <a:rPr lang="de-DE" dirty="0"/>
+              <a:t>- Überlappung: Boxen stark überlappen-&gt; einzelne Merkmal allein  nicht aussagekräftig genug für einfache Unterscheidung. In  KI-Anwendung mit anderen kombinieren- Größe der Boxen: </a:t>
+            </a:r>
+            <a:r>
+              <a:rPr lang="de-DE" dirty="0" err="1"/>
+              <a:t>stabilität</a:t>
+            </a:r>
+            <a:r>
+              <a:rPr lang="de-DE" dirty="0"/>
+              <a:t> von Merkmalen. Große Boxen -&gt; große Varianz, weniger sinnvoll für Klassifikation</a:t>
+            </a:r>
+            <a:br>
+              <a:rPr lang="de-DE" dirty="0"/>
+            </a:br>
+            <a:r>
+              <a:rPr lang="de-DE" dirty="0"/>
+              <a:t>- Ausreißer: auf Messfehler, Rauschen oder besondere Anomalien im Zahnrad hinweisen(die für eine KI als „Herausforderung“ oder „Indikator“ dienen </a:t>
+            </a:r>
+            <a:r>
+              <a:rPr lang="de-DE"/>
+              <a:t>können)</a:t>
+            </a:r>
+          </a:p>
+          <a:p>
+            <a:pPr marL="171450" indent="-171450">
+              <a:buFontTx/>
+              <a:buChar char="-"/>
+            </a:pPr>
+            <a:r>
+              <a:rPr lang="de-DE"/>
+              <a:t>=&gt; </a:t>
+            </a:r>
+            <a:r>
+              <a:rPr lang="de-DE" dirty="0"/>
+              <a:t>Zentral für Verständnis, nehmen trotzdem alle\man könnte gewichten</a:t>
+            </a:r>
           </a:p>
         </p:txBody>
       </p:sp>
@@ -2420,7 +2475,54 @@
             </a:r>
           </a:p>
           <a:p>
-            <a:endParaRPr lang="de-DE" dirty="0"/>
+            <a:pPr marL="171450" indent="-171450">
+              <a:buFontTx/>
+              <a:buChar char="-"/>
+            </a:pPr>
+            <a:r>
+              <a:rPr lang="de-DE" dirty="0"/>
+              <a:t>Lage der Mediane zueinander: wenn Mediane von Zahnrädern aus versch. </a:t>
+            </a:r>
+            <a:r>
+              <a:rPr lang="de-DE" dirty="0" err="1"/>
+              <a:t>klassen</a:t>
+            </a:r>
+            <a:r>
+              <a:rPr lang="de-DE" dirty="0"/>
+              <a:t> unterschiedlich stark sind hat dieses Merkmal einen indikativen Charakter  </a:t>
+            </a:r>
+            <a:br>
+              <a:rPr lang="de-DE" dirty="0"/>
+            </a:br>
+            <a:r>
+              <a:rPr lang="de-DE" dirty="0"/>
+              <a:t>- Überlappung: Boxen stark überlappen-&gt; einzelne Merkmal allein  nicht aussagekräftig genug für einfache Unterscheidung. In  KI-Anwendung mit anderen kombinieren- Größe der Boxen: </a:t>
+            </a:r>
+            <a:r>
+              <a:rPr lang="de-DE" dirty="0" err="1"/>
+              <a:t>stabilität</a:t>
+            </a:r>
+            <a:r>
+              <a:rPr lang="de-DE" dirty="0"/>
+              <a:t> von Merkmalen. Große Boxen -&gt; große Varianz, weniger sinnvoll für Klassifikation</a:t>
+            </a:r>
+            <a:br>
+              <a:rPr lang="de-DE" dirty="0"/>
+            </a:br>
+            <a:r>
+              <a:rPr lang="de-DE" dirty="0"/>
+              <a:t>- Ausreißer: auf Messfehler, Rauschen oder besondere Anomalien im Zahnrad hinweisen(die für eine KI als „Herausforderung“ oder „Indikator“ dienen können)</a:t>
+            </a:r>
+          </a:p>
+          <a:p>
+            <a:pPr marL="171450" indent="-171450">
+              <a:buFontTx/>
+              <a:buChar char="-"/>
+            </a:pPr>
+            <a:r>
+              <a:rPr lang="de-DE" dirty="0"/>
+              <a:t>=&gt; Zentral für Verständnis, nehmen trotzdem alle\man könnte gewichten</a:t>
+            </a:r>
           </a:p>
         </p:txBody>
       </p:sp>
@@ -2530,10 +2632,9 @@
           <a:lstStyle/>
           <a:p>
             <a:r>
-              <a:rPr lang="de-DE"/>
-              <a:t>(S)</a:t>
-            </a:r>
-            <a:endParaRPr lang="de-DE" dirty="0"/>
+              <a:rPr lang="de-DE" dirty="0"/>
+              <a:t>T</a:t>
+            </a:r>
           </a:p>
         </p:txBody>
       </p:sp>
@@ -9253,55 +9354,6 @@
               <a:t>Explorative Datenanalyse</a:t>
             </a:r>
             <a:endParaRPr lang="de-DE" dirty="0"/>
-          </a:p>
-        </p:txBody>
-      </p:sp>
-      <p:sp>
-        <p:nvSpPr>
-          <p:cNvPr id="6" name="Textfeld 5">
-            <a:extLst>
-              <a:ext uri="{FF2B5EF4-FFF2-40B4-BE49-F238E27FC236}">
-                <a16:creationId xmlns:a16="http://schemas.microsoft.com/office/drawing/2014/main" id="{DBCE15F3-9C3E-D3E2-9110-0C55D36695D8}"/>
-              </a:ext>
-            </a:extLst>
-          </p:cNvPr>
-          <p:cNvSpPr txBox="1"/>
-          <p:nvPr/>
-        </p:nvSpPr>
-        <p:spPr>
-          <a:xfrm>
-            <a:off x="625186" y="5486910"/>
-            <a:ext cx="10941627" cy="461665"/>
-          </a:xfrm>
-          <a:prstGeom prst="rect">
-            <a:avLst/>
-          </a:prstGeom>
-          <a:noFill/>
-        </p:spPr>
-        <p:txBody>
-          <a:bodyPr wrap="square" rtlCol="0">
-            <a:spAutoFit/>
-          </a:bodyPr>
-          <a:lstStyle/>
-          <a:p>
-            <a:r>
-              <a:rPr lang="de-DE" dirty="0">
-                <a:latin typeface="+mn-lt"/>
-              </a:rPr>
-              <a:t>Prüfen: </a:t>
-            </a:r>
-            <a:r>
-              <a:rPr lang="de-DE" dirty="0" err="1">
-                <a:latin typeface="+mn-lt"/>
-              </a:rPr>
-              <a:t>specture</a:t>
-            </a:r>
-            <a:r>
-              <a:rPr lang="de-DE" dirty="0">
-                <a:latin typeface="+mn-lt"/>
-              </a:rPr>
-              <a:t> Rolloff … (Tim)</a:t>
-            </a:r>
           </a:p>
         </p:txBody>
       </p:sp>

</xml_diff>

<commit_message>
final pptx for Task_2
</commit_message>
<xml_diff>
--- a/Task_2/Task2Powerpoint.pptx
+++ b/Task_2/Task2Powerpoint.pptx
@@ -2366,11 +2366,7 @@
             </a:br>
             <a:r>
               <a:rPr lang="de-DE" dirty="0"/>
-              <a:t>- Ausreißer: auf Messfehler, Rauschen oder besondere Anomalien im Zahnrad hinweisen(die für eine KI als „Herausforderung“ oder „Indikator“ dienen </a:t>
-            </a:r>
-            <a:r>
-              <a:rPr lang="de-DE"/>
-              <a:t>können)</a:t>
+              <a:t>- Ausreißer: auf Messfehler, Rauschen oder besondere Anomalien im Zahnrad hinweisen(die für eine KI als „Herausforderung“ oder „Indikator“ dienen können)</a:t>
             </a:r>
           </a:p>
           <a:p>
@@ -2379,12 +2375,8 @@
               <a:buChar char="-"/>
             </a:pPr>
             <a:r>
-              <a:rPr lang="de-DE"/>
-              <a:t>=&gt; </a:t>
-            </a:r>
-            <a:r>
               <a:rPr lang="de-DE" dirty="0"/>
-              <a:t>Zentral für Verständnis, nehmen trotzdem alle\man könnte gewichten</a:t>
+              <a:t>=&gt; Zentral für Verständnis, nehmen trotzdem alle\man könnte gewichten</a:t>
             </a:r>
           </a:p>
         </p:txBody>
@@ -6563,7 +6555,27 @@
             </a:pPr>
             <a:r>
               <a:rPr lang="de-DE" dirty="0"/>
-              <a:t>Die PCA-Darstellung der extrahierten Merkmale zeigt, dass Z05 klar separiert von den übrigen Zahnrädern liegt. Dies deutet darauf hin, dass sich dessen Signalcharakteristik signifikant unterscheidet. </a:t>
+              <a:t>PCA-Darstellung der extrahierten Merkmale zeigt</a:t>
+            </a:r>
+          </a:p>
+          <a:p>
+            <a:pPr lvl="1">
+              <a:buFont typeface="Arial" panose="020B0604020202020204" pitchFamily="34" charset="0"/>
+              <a:buChar char="•"/>
+            </a:pPr>
+            <a:r>
+              <a:rPr lang="de-DE" dirty="0"/>
+              <a:t>Z05 klar separiert von den übrigen Zahnrädern</a:t>
+            </a:r>
+          </a:p>
+          <a:p>
+            <a:pPr lvl="1">
+              <a:buFont typeface="Arial" panose="020B0604020202020204" pitchFamily="34" charset="0"/>
+              <a:buChar char="•"/>
+            </a:pPr>
+            <a:r>
+              <a:rPr lang="de-DE" dirty="0"/>
+              <a:t>Signalcharakteristik von Z05 unterscheidet sich signifikant von den anderen </a:t>
             </a:r>
           </a:p>
           <a:p>
@@ -6573,7 +6585,17 @@
             </a:pPr>
             <a:r>
               <a:rPr lang="de-DE" dirty="0"/>
-              <a:t>Damit konnten die Signale in eine Merkmalsform überführt werden, die sich grundsätzlich für eine automatisierte Klassifikation oder Anomalie Erkennung eignet.</a:t>
+              <a:t>Signale wurden in eine Merkmalsform überführt </a:t>
+            </a:r>
+          </a:p>
+          <a:p>
+            <a:pPr lvl="1">
+              <a:buFont typeface="Arial" panose="020B0604020202020204" pitchFamily="34" charset="0"/>
+              <a:buChar char="•"/>
+            </a:pPr>
+            <a:r>
+              <a:rPr lang="de-DE" dirty="0"/>
+              <a:t>Eignet sich für eine automatisierte Klassifikation oder Anomalie Erkennung</a:t>
             </a:r>
           </a:p>
         </p:txBody>

</xml_diff>